<commit_message>
Rename the project to finLM everywhere
Three names were in play: finLM in all the prose, finLLM in the repo URL
and paths, and llmfin as the package. The package name stays (renaming 193
references and the entry points buys nothing), but the repo name now
matches what every document already called it.

Rebuilds the overview deck so its footer URL matches, and corrects a stale
test count in the site's og:description.
</commit_message>
<xml_diff>
--- a/finLM_overview.pptx
+++ b/finLM_overview.pptx
@@ -2372,7 +2372,7 @@
                 <a:ea typeface="Calibri" pitchFamily="34" charset="-122"/>
                 <a:cs typeface="Calibri" pitchFamily="34" charset="-120"/>
               </a:rPr>
-              <a:t>Hasil  ·  github.com/hasil7677/finLLM</a:t>
+              <a:t>Hasil  ·  github.com/hasil7677/finLM</a:t>
             </a:r>
             <a:endParaRPr lang="en-US" sz="1200" dirty="0"/>
           </a:p>
@@ -3780,7 +3780,7 @@
                 <a:ea typeface="Cambria" pitchFamily="34" charset="-122"/>
                 <a:cs typeface="Cambria" pitchFamily="34" charset="-120"/>
               </a:rPr>
-              <a:t>finLM  ·  Hasil  ·  github.com/hasil7677/finLLM</a:t>
+              <a:t>finLM  ·  Hasil  ·  github.com/hasil7677/finLM</a:t>
             </a:r>
             <a:endParaRPr lang="en-US" sz="1500" dirty="0"/>
           </a:p>

</xml_diff>